<commit_message>
Actualizar honorarios en la presentación de Casa Outlet
Meses 1-3 pasan de $950.000 a $1.100.000/mes; la tarifa desde el mes 4
($1.300.000/mes) y el presupuesto de pauta se mantienen sin cambios.

Co-Authored-By: Claude Sonnet 5 <noreply@anthropic.com>
Claude-Session: https://claude.ai/code/session_01SmkHKcxHsRiRKSPUZSC2qb
</commit_message>
<xml_diff>
--- a/Diana - Casa Outlet (Muebles y Colchones)/Casa_Outlet_Meta_Ads.pptx
+++ b/Diana - Casa Outlet (Muebles y Colchones)/Casa_Outlet_Meta_Ads.pptx
@@ -1332,7 +1332,7 @@
               <a:rPr lang="en-US" dirty="0"/>
               <a:t>OBJETIVO: Presentar con claridad las dos líneas de inversión necesarias para poner en marcha el sistema, sin mezclar honorarios de gestión con presupuesto publicitario.
 MENSAJE PRINCIPAL: Son dos inversiones independientes: unos honorarios de gestión estratégica y un presupuesto de pauta que pertenece siempre a Casa Outlet.
-QUÉ EXPLICAR: Los honorarios de gestión inician en $950.000 mensuales durante los primeros 3 meses como precio de lanzamiento, y pasan a la tarifa full de $1.300.000 mensuales desde el mes 4. Aparte, el presupuesto mínimo recomendado de pauta en Meta Ads es de $1.500.000 mensuales.</a:t>
+QUÉ EXPLICAR: Los honorarios de gestión inician en $1.100.000 mensuales durante los primeros 3 meses como precio de lanzamiento, y pasan a la tarifa full de $1.300.000 mensuales desde el mes 4. Aparte, el presupuesto mínimo recomendado de pauta en Meta Ads es de $1.500.000 mensuales.</a:t>
             </a:r>
             <a:endParaRPr lang="en-US" dirty="0"/>
           </a:p>
@@ -10052,7 +10052,7 @@
                 <a:ea typeface="Cambria" pitchFamily="34" charset="-122"/>
                 <a:cs typeface="Cambria" pitchFamily="34" charset="-120"/>
               </a:rPr>
-              <a:t>$950.000</a:t>
+              <a:t>$1.100.000</a:t>
             </a:r>
             <a:pPr indent="0" marL="0">
               <a:buNone/>

</xml_diff>